<commit_message>
DRE de 3 anos com Zelo Empresas cobrado por funcionário: EBIT positivo no ano 2
A margem por atendimento (~21%) sozinha não paga a estrutura. O Zelo Empresas passa
a cobrar R$ 5 por funcionário ao mês (todos os funcionários), receita recorrente que
vira margem e traz famílias sem custo de aquisição. Planilha refeita como DRE anual
(gerada por docs/gerar_ebit.py), com aba de sensibilidade; slides 7 e A2, PPTX,
estratégia e guias atualizados.

Co-Authored-By: Claude Opus 5.5 <noreply@anthropic.com>
Claude-Session: https://claude.ai/code/session_01CWySyzJUbkw2R6z9dLT82G
</commit_message>
<xml_diff>
--- a/pitch/zelo-pitch.pptx
+++ b/pitch/zelo-pitch.pptx
@@ -653,7 +653,7 @@
           <a:lstStyle/>
           <a:p>
             <a:r>
-              <a:t>APÊNDICE: EBIT preliminar. O negócio fica de pé com escala, por volta de 7.300 atendimentos por mês em São Paulo. As alavancas são o preço do acompanhante, o percentual que o Zelo retém e o Zelo Empresas.</a:t>
+              <a:t>APÊNDICE: DRE de 3 anos. Ano 1 é investimento: cerca de R$ 370 mil negativos. No ano 2 o EBIT fica positivo e no ano 3 chega a R$ 2,2 milhões, pagando o investimento ainda no ano 3. O motor é o Zelo Empresas: R$ 5 por funcionário ao mês, receita recorrente quase sem custo. Sem ele, o negócio ficaria no vermelho nos três anos, com margem de cerca de R$ 58 por atendimento. Por isso o piloto pede 3 empresas. Se perguntarem: 45 mil funcionários cobertos no ano 3 equivalem a 90 empresas de 500 pessoas; 5% deles usando por mês.</a:t>
             </a:r>
           </a:p>
         </p:txBody>
@@ -1143,7 +1143,7 @@
           <a:lstStyle/>
           <a:p>
             <a:r>
-              <a:t>[2:15–2:35] Como ganhamos dinheiro: o serviço é pago por atendimento e o Zelo fica com cerca de 21% depois de pagar a acompanhante, o carro, impostos e IA. Em um atendimento de R$ 275, sobram cerca de R$ 58. Três planos: Grátis, com taxa de R$ 15 por atendimento; Zelo+, por R$ 29,90 ao mês, sem taxa; e Zelo Empresas, em que o RH paga como benefício, porque cada falta para levar os pais custa caro para a empresa também.</a:t>
+              <a:t>[2:15–2:35] Como ganhamos dinheiro: o serviço é pago por atendimento e o Zelo fica com cerca de 21% depois de pagar a acompanhante, o carro, impostos e IA. Em um atendimento de R$ 275, sobram cerca de R$ 58. Três planos: Grátis, com taxa de R$ 15 por atendimento; Zelo+, por R$ 29,90 ao mês, sem taxa; e Zelo Empresas: a empresa paga R$ 5 por funcionário ao mês, como benefício, porque cada falta para levar os pais custa caro para ela também. Essa mensalidade é o que paga a estrutura: com ela, o Zelo fica no azul no ano 2 (detalhes no apêndice).</a:t>
             </a:r>
           </a:p>
         </p:txBody>
@@ -5418,7 +5418,7 @@
                 <a:cs typeface="Source Sans 3"/>
                 <a:sym typeface="Source Sans 3"/>
               </a:rPr>
-              <a:t>EBIT PRELIMINAR (HIPÓTESES)</a:t>
+              <a:t>DRE PRELIMINAR DE 3 ANOS (HIPÓTESES)</a:t>
             </a:r>
           </a:p>
         </p:txBody>
@@ -5458,7 +5458,7 @@
                 <a:cs typeface="Lexend SemiBold"/>
                 <a:sym typeface="Lexend SemiBold"/>
               </a:rPr>
-              <a:t>O negócio para em pé com escala.</a:t>
+              <a:t>No azul a partir do ano 2, puxado pelo B2B.</a:t>
             </a:r>
           </a:p>
         </p:txBody>
@@ -5472,11 +5472,11 @@
         <p:spPr>
           <a:xfrm>
             <a:off x="1143000" y="2470696"/>
-            <a:ext cx="16002000" cy="5153025"/>
+            <a:ext cx="16002000" cy="5895975"/>
           </a:xfrm>
           <a:prstGeom prst="roundRect">
             <a:avLst>
-              <a:gd name="adj" fmla="val 4436"/>
+              <a:gd name="adj" fmla="val 3877"/>
             </a:avLst>
           </a:prstGeom>
           <a:solidFill>
@@ -5500,8 +5500,8 @@
         </p:nvSpPr>
         <p:spPr>
           <a:xfrm rot="16200000">
-            <a:off x="3662362" y="-48667"/>
-            <a:ext cx="685800" cy="5724525"/>
+            <a:off x="4449514" y="-835819"/>
+            <a:ext cx="685800" cy="7298829"/>
           </a:xfrm>
           <a:prstGeom prst="round1Rect">
             <a:avLst>
@@ -5530,7 +5530,7 @@
         <p:spPr>
           <a:xfrm>
             <a:off x="1143000" y="3137446"/>
-            <a:ext cx="5724525" cy="19050"/>
+            <a:ext cx="7298829" cy="19050"/>
           </a:xfrm>
           <a:prstGeom prst="rect">
             <a:avLst/>
@@ -5557,7 +5557,7 @@
         <p:spPr>
           <a:xfrm>
             <a:off x="1390650" y="2629878"/>
-            <a:ext cx="5942648" cy="333375"/>
+            <a:ext cx="7674382" cy="333375"/>
           </a:xfrm>
           <a:prstGeom prst="rect">
             <a:avLst/>
@@ -5583,7 +5583,7 @@
                 <a:cs typeface="Lexend SemiBold"/>
                 <a:sym typeface="Lexend SemiBold"/>
               </a:rPr>
-              <a:t>R$ por mês</a:t>
+              <a:t>R$ por ano</a:t>
             </a:r>
           </a:p>
         </p:txBody>
@@ -5596,8 +5596,8 @@
         </p:nvSpPr>
         <p:spPr>
           <a:xfrm>
-            <a:off x="6867525" y="2470696"/>
-            <a:ext cx="3245941" cy="685800"/>
+            <a:off x="8441829" y="2470696"/>
+            <a:ext cx="3036689" cy="685800"/>
           </a:xfrm>
           <a:prstGeom prst="rect">
             <a:avLst/>
@@ -5623,8 +5623,8 @@
         </p:nvSpPr>
         <p:spPr>
           <a:xfrm>
-            <a:off x="6867525" y="3137446"/>
-            <a:ext cx="3245941" cy="19050"/>
+            <a:off x="8441829" y="3137446"/>
+            <a:ext cx="3036689" cy="19050"/>
           </a:xfrm>
           <a:prstGeom prst="rect">
             <a:avLst/>
@@ -5650,8 +5650,8 @@
         </p:nvSpPr>
         <p:spPr>
           <a:xfrm>
-            <a:off x="6649611" y="2629878"/>
-            <a:ext cx="3216206" cy="333375"/>
+            <a:off x="8244840" y="2629878"/>
+            <a:ext cx="2986028" cy="333375"/>
           </a:xfrm>
           <a:prstGeom prst="rect">
             <a:avLst/>
@@ -5677,7 +5677,7 @@
                 <a:cs typeface="Lexend SemiBold"/>
                 <a:sym typeface="Lexend SemiBold"/>
               </a:rPr>
-              <a:t>Piloto (mês 6)</a:t>
+              <a:t>Ano 1</a:t>
             </a:r>
           </a:p>
         </p:txBody>
@@ -5690,8 +5690,8 @@
         </p:nvSpPr>
         <p:spPr>
           <a:xfrm>
-            <a:off x="10113466" y="2470696"/>
-            <a:ext cx="3116461" cy="685800"/>
+            <a:off x="11478518" y="2470696"/>
+            <a:ext cx="2833092" cy="685800"/>
           </a:xfrm>
           <a:prstGeom prst="rect">
             <a:avLst/>
@@ -5717,8 +5717,8 @@
         </p:nvSpPr>
         <p:spPr>
           <a:xfrm>
-            <a:off x="10113466" y="3137446"/>
-            <a:ext cx="3116461" cy="19050"/>
+            <a:off x="11478518" y="3137446"/>
+            <a:ext cx="2833092" cy="19050"/>
           </a:xfrm>
           <a:prstGeom prst="rect">
             <a:avLst/>
@@ -5744,8 +5744,8 @@
         </p:nvSpPr>
         <p:spPr>
           <a:xfrm>
-            <a:off x="9908500" y="2629878"/>
-            <a:ext cx="3073777" cy="333375"/>
+            <a:off x="11301889" y="2629878"/>
+            <a:ext cx="2762071" cy="333375"/>
           </a:xfrm>
           <a:prstGeom prst="rect">
             <a:avLst/>
@@ -5771,7 +5771,7 @@
                 <a:cs typeface="Lexend SemiBold"/>
                 <a:sym typeface="Lexend SemiBold"/>
               </a:rPr>
-              <a:t>Fim do ano 1</a:t>
+              <a:t>Ano 2</a:t>
             </a:r>
           </a:p>
         </p:txBody>
@@ -5784,8 +5784,8 @@
         </p:nvSpPr>
         <p:spPr>
           <a:xfrm>
-            <a:off x="13229927" y="2470696"/>
-            <a:ext cx="3915073" cy="685800"/>
+            <a:off x="14311610" y="2470696"/>
+            <a:ext cx="2833390" cy="685800"/>
           </a:xfrm>
           <a:prstGeom prst="round1Rect">
             <a:avLst>
@@ -5813,8 +5813,8 @@
         </p:nvSpPr>
         <p:spPr>
           <a:xfrm>
-            <a:off x="13229927" y="3137446"/>
-            <a:ext cx="3915073" cy="19050"/>
+            <a:off x="14311610" y="3137446"/>
+            <a:ext cx="2833390" cy="19050"/>
           </a:xfrm>
           <a:prstGeom prst="rect">
             <a:avLst/>
@@ -5840,8 +5840,8 @@
         </p:nvSpPr>
         <p:spPr>
           <a:xfrm>
-            <a:off x="12945100" y="2629878"/>
-            <a:ext cx="3952250" cy="333375"/>
+            <a:off x="14134951" y="2629878"/>
+            <a:ext cx="2762399" cy="333375"/>
           </a:xfrm>
           <a:prstGeom prst="rect">
             <a:avLst/>
@@ -5867,7 +5867,7 @@
                 <a:cs typeface="Lexend SemiBold"/>
                 <a:sym typeface="Lexend SemiBold"/>
               </a:rPr>
-              <a:t>Ano 3 (escala SP)</a:t>
+              <a:t>Ano 3</a:t>
             </a:r>
           </a:p>
         </p:txBody>
@@ -5881,7 +5881,7 @@
         <p:spPr>
           <a:xfrm>
             <a:off x="1143000" y="3880396"/>
-            <a:ext cx="5724525" cy="19050"/>
+            <a:ext cx="7298829" cy="19050"/>
           </a:xfrm>
           <a:prstGeom prst="rect">
             <a:avLst/>
@@ -5908,7 +5908,7 @@
         <p:spPr>
           <a:xfrm>
             <a:off x="1390650" y="3292132"/>
-            <a:ext cx="5942648" cy="381000"/>
+            <a:ext cx="7674382" cy="381000"/>
           </a:xfrm>
           <a:prstGeom prst="rect">
             <a:avLst/>
@@ -5934,7 +5934,7 @@
                 <a:cs typeface="Source Sans 3"/>
                 <a:sym typeface="Source Sans 3"/>
               </a:rPr>
-              <a:t>Atendimentos por mês</a:t>
+              <a:t>Atendimentos por mês (média)</a:t>
             </a:r>
           </a:p>
         </p:txBody>
@@ -5947,8 +5947,8 @@
         </p:nvSpPr>
         <p:spPr>
           <a:xfrm>
-            <a:off x="6867525" y="3880396"/>
-            <a:ext cx="3245941" cy="19050"/>
+            <a:off x="8441829" y="3880396"/>
+            <a:ext cx="3036689" cy="19050"/>
           </a:xfrm>
           <a:prstGeom prst="rect">
             <a:avLst/>
@@ -5974,8 +5974,8 @@
         </p:nvSpPr>
         <p:spPr>
           <a:xfrm>
-            <a:off x="6649611" y="3292132"/>
-            <a:ext cx="3216206" cy="381000"/>
+            <a:off x="8244840" y="3292132"/>
+            <a:ext cx="2986028" cy="381000"/>
           </a:xfrm>
           <a:prstGeom prst="rect">
             <a:avLst/>
@@ -6001,7 +6001,7 @@
                 <a:cs typeface="Source Sans 3"/>
                 <a:sym typeface="Source Sans 3"/>
               </a:rPr>
-              <a:t>300</a:t>
+              <a:t>275</a:t>
             </a:r>
           </a:p>
         </p:txBody>
@@ -6014,8 +6014,8 @@
         </p:nvSpPr>
         <p:spPr>
           <a:xfrm>
-            <a:off x="10113466" y="3880396"/>
-            <a:ext cx="3116461" cy="19050"/>
+            <a:off x="11478518" y="3880396"/>
+            <a:ext cx="2833092" cy="19050"/>
           </a:xfrm>
           <a:prstGeom prst="rect">
             <a:avLst/>
@@ -6041,8 +6041,8 @@
         </p:nvSpPr>
         <p:spPr>
           <a:xfrm>
-            <a:off x="9908500" y="3292132"/>
-            <a:ext cx="3073777" cy="381000"/>
+            <a:off x="11301889" y="3292132"/>
+            <a:ext cx="2762071" cy="381000"/>
           </a:xfrm>
           <a:prstGeom prst="rect">
             <a:avLst/>
@@ -6068,7 +6068,7 @@
                 <a:cs typeface="Source Sans 3"/>
                 <a:sym typeface="Source Sans 3"/>
               </a:rPr>
-              <a:t>1.500</a:t>
+              <a:t>1.400</a:t>
             </a:r>
           </a:p>
         </p:txBody>
@@ -6081,8 +6081,8 @@
         </p:nvSpPr>
         <p:spPr>
           <a:xfrm>
-            <a:off x="13229927" y="3880396"/>
-            <a:ext cx="3915073" cy="19050"/>
+            <a:off x="14311610" y="3880396"/>
+            <a:ext cx="2833390" cy="19050"/>
           </a:xfrm>
           <a:prstGeom prst="rect">
             <a:avLst/>
@@ -6108,8 +6108,8 @@
         </p:nvSpPr>
         <p:spPr>
           <a:xfrm>
-            <a:off x="12945100" y="3292132"/>
-            <a:ext cx="3952250" cy="381000"/>
+            <a:off x="14134951" y="3292132"/>
+            <a:ext cx="2762399" cy="381000"/>
           </a:xfrm>
           <a:prstGeom prst="rect">
             <a:avLst/>
@@ -6135,7 +6135,7 @@
                 <a:cs typeface="Source Sans 3"/>
                 <a:sym typeface="Source Sans 3"/>
               </a:rPr>
-              <a:t>8.000</a:t>
+              <a:t>4.250</a:t>
             </a:r>
           </a:p>
         </p:txBody>
@@ -6149,7 +6149,7 @@
         <p:spPr>
           <a:xfrm>
             <a:off x="1143000" y="4623346"/>
-            <a:ext cx="5724525" cy="19050"/>
+            <a:ext cx="7298829" cy="19050"/>
           </a:xfrm>
           <a:prstGeom prst="rect">
             <a:avLst/>
@@ -6176,7 +6176,7 @@
         <p:spPr>
           <a:xfrm>
             <a:off x="1390650" y="4035082"/>
-            <a:ext cx="5942648" cy="381000"/>
+            <a:ext cx="7674382" cy="381000"/>
           </a:xfrm>
           <a:prstGeom prst="rect">
             <a:avLst/>
@@ -6202,7 +6202,7 @@
                 <a:cs typeface="Source Sans 3"/>
                 <a:sym typeface="Source Sans 3"/>
               </a:rPr>
-              <a:t>Entradas totais</a:t>
+              <a:t>Funcionários cobertos (Zelo Empresas)</a:t>
             </a:r>
           </a:p>
         </p:txBody>
@@ -6215,8 +6215,8 @@
         </p:nvSpPr>
         <p:spPr>
           <a:xfrm>
-            <a:off x="6867525" y="4623346"/>
-            <a:ext cx="3245941" cy="19050"/>
+            <a:off x="8441829" y="4623346"/>
+            <a:ext cx="3036689" cy="19050"/>
           </a:xfrm>
           <a:prstGeom prst="rect">
             <a:avLst/>
@@ -6242,8 +6242,8 @@
         </p:nvSpPr>
         <p:spPr>
           <a:xfrm>
-            <a:off x="6649611" y="4035082"/>
-            <a:ext cx="3216206" cy="381000"/>
+            <a:off x="8244840" y="4035082"/>
+            <a:ext cx="2986028" cy="381000"/>
           </a:xfrm>
           <a:prstGeom prst="rect">
             <a:avLst/>
@@ -6269,7 +6269,7 @@
                 <a:cs typeface="Source Sans 3"/>
                 <a:sym typeface="Source Sans 3"/>
               </a:rPr>
-              <a:t>73 mil</a:t>
+              <a:t>2.500</a:t>
             </a:r>
           </a:p>
         </p:txBody>
@@ -6282,8 +6282,8 @@
         </p:nvSpPr>
         <p:spPr>
           <a:xfrm>
-            <a:off x="10113466" y="4623346"/>
-            <a:ext cx="3116461" cy="19050"/>
+            <a:off x="11478518" y="4623346"/>
+            <a:ext cx="2833092" cy="19050"/>
           </a:xfrm>
           <a:prstGeom prst="rect">
             <a:avLst/>
@@ -6309,8 +6309,8 @@
         </p:nvSpPr>
         <p:spPr>
           <a:xfrm>
-            <a:off x="9908500" y="4035082"/>
-            <a:ext cx="3073777" cy="381000"/>
+            <a:off x="11301889" y="4035082"/>
+            <a:ext cx="2762071" cy="381000"/>
           </a:xfrm>
           <a:prstGeom prst="rect">
             <a:avLst/>
@@ -6336,7 +6336,7 @@
                 <a:cs typeface="Source Sans 3"/>
                 <a:sym typeface="Source Sans 3"/>
               </a:rPr>
-              <a:t>368 mil</a:t>
+              <a:t>15 mil</a:t>
             </a:r>
           </a:p>
         </p:txBody>
@@ -6349,8 +6349,8 @@
         </p:nvSpPr>
         <p:spPr>
           <a:xfrm>
-            <a:off x="13229927" y="4623346"/>
-            <a:ext cx="3915073" cy="19050"/>
+            <a:off x="14311610" y="4623346"/>
+            <a:ext cx="2833390" cy="19050"/>
           </a:xfrm>
           <a:prstGeom prst="rect">
             <a:avLst/>
@@ -6376,8 +6376,8 @@
         </p:nvSpPr>
         <p:spPr>
           <a:xfrm>
-            <a:off x="12945100" y="4035082"/>
-            <a:ext cx="3952250" cy="381000"/>
+            <a:off x="14134951" y="4035082"/>
+            <a:ext cx="2762399" cy="381000"/>
           </a:xfrm>
           <a:prstGeom prst="rect">
             <a:avLst/>
@@ -6403,7 +6403,7 @@
                 <a:cs typeface="Source Sans 3"/>
                 <a:sym typeface="Source Sans 3"/>
               </a:rPr>
-              <a:t>1,97 mi</a:t>
+              <a:t>45 mil</a:t>
             </a:r>
           </a:p>
         </p:txBody>
@@ -6417,7 +6417,7 @@
         <p:spPr>
           <a:xfrm>
             <a:off x="1143000" y="5366296"/>
-            <a:ext cx="5724525" cy="19050"/>
+            <a:ext cx="7298829" cy="19050"/>
           </a:xfrm>
           <a:prstGeom prst="rect">
             <a:avLst/>
@@ -6444,7 +6444,7 @@
         <p:spPr>
           <a:xfrm>
             <a:off x="1390650" y="4778032"/>
-            <a:ext cx="5942648" cy="381000"/>
+            <a:ext cx="7674382" cy="381000"/>
           </a:xfrm>
           <a:prstGeom prst="rect">
             <a:avLst/>
@@ -6470,7 +6470,7 @@
                 <a:cs typeface="Source Sans 3"/>
                 <a:sym typeface="Source Sans 3"/>
               </a:rPr>
-              <a:t>Margem de contribuição</a:t>
+              <a:t>Entradas totais</a:t>
             </a:r>
           </a:p>
         </p:txBody>
@@ -6483,8 +6483,8 @@
         </p:nvSpPr>
         <p:spPr>
           <a:xfrm>
-            <a:off x="6867525" y="5366296"/>
-            <a:ext cx="3245941" cy="19050"/>
+            <a:off x="8441829" y="5366296"/>
+            <a:ext cx="3036689" cy="19050"/>
           </a:xfrm>
           <a:prstGeom prst="rect">
             <a:avLst/>
@@ -6510,8 +6510,8 @@
         </p:nvSpPr>
         <p:spPr>
           <a:xfrm>
-            <a:off x="6649611" y="4778032"/>
-            <a:ext cx="3216206" cy="381000"/>
+            <a:off x="8244840" y="4778032"/>
+            <a:ext cx="2986028" cy="381000"/>
           </a:xfrm>
           <a:prstGeom prst="rect">
             <a:avLst/>
@@ -6537,7 +6537,7 @@
                 <a:cs typeface="Source Sans 3"/>
                 <a:sym typeface="Source Sans 3"/>
               </a:rPr>
-              <a:t>16 mil (22%)</a:t>
+              <a:t>940 mil</a:t>
             </a:r>
           </a:p>
         </p:txBody>
@@ -6550,8 +6550,8 @@
         </p:nvSpPr>
         <p:spPr>
           <a:xfrm>
-            <a:off x="10113466" y="5366296"/>
-            <a:ext cx="3116461" cy="19050"/>
+            <a:off x="11478518" y="5366296"/>
+            <a:ext cx="2833092" cy="19050"/>
           </a:xfrm>
           <a:prstGeom prst="rect">
             <a:avLst/>
@@ -6577,8 +6577,8 @@
         </p:nvSpPr>
         <p:spPr>
           <a:xfrm>
-            <a:off x="9908500" y="4778032"/>
-            <a:ext cx="3073777" cy="381000"/>
+            <a:off x="11301889" y="4778032"/>
+            <a:ext cx="2762071" cy="381000"/>
           </a:xfrm>
           <a:prstGeom prst="rect">
             <a:avLst/>
@@ -6604,7 +6604,7 @@
                 <a:cs typeface="Source Sans 3"/>
                 <a:sym typeface="Source Sans 3"/>
               </a:rPr>
-              <a:t>82 mil (22%)</a:t>
+              <a:t>4,9 mi</a:t>
             </a:r>
           </a:p>
         </p:txBody>
@@ -6617,8 +6617,8 @@
         </p:nvSpPr>
         <p:spPr>
           <a:xfrm>
-            <a:off x="13229927" y="5366296"/>
-            <a:ext cx="3915073" cy="19050"/>
+            <a:off x="14311610" y="5366296"/>
+            <a:ext cx="2833390" cy="19050"/>
           </a:xfrm>
           <a:prstGeom prst="rect">
             <a:avLst/>
@@ -6644,8 +6644,8 @@
         </p:nvSpPr>
         <p:spPr>
           <a:xfrm>
-            <a:off x="12945100" y="4778032"/>
-            <a:ext cx="3952250" cy="381000"/>
+            <a:off x="14134951" y="4778032"/>
+            <a:ext cx="2762399" cy="381000"/>
           </a:xfrm>
           <a:prstGeom prst="rect">
             <a:avLst/>
@@ -6671,7 +6671,7 @@
                 <a:cs typeface="Source Sans 3"/>
                 <a:sym typeface="Source Sans 3"/>
               </a:rPr>
-              <a:t>442 mil (22%)</a:t>
+              <a:t>14,7 mi</a:t>
             </a:r>
           </a:p>
         </p:txBody>
@@ -6685,7 +6685,7 @@
         <p:spPr>
           <a:xfrm>
             <a:off x="1143000" y="6109246"/>
-            <a:ext cx="5724525" cy="19050"/>
+            <a:ext cx="7298829" cy="19050"/>
           </a:xfrm>
           <a:prstGeom prst="rect">
             <a:avLst/>
@@ -6712,7 +6712,7 @@
         <p:spPr>
           <a:xfrm>
             <a:off x="1390650" y="5520982"/>
-            <a:ext cx="5942648" cy="381000"/>
+            <a:ext cx="7674382" cy="381000"/>
           </a:xfrm>
           <a:prstGeom prst="rect">
             <a:avLst/>
@@ -6738,7 +6738,7 @@
                 <a:cs typeface="Source Sans 3"/>
                 <a:sym typeface="Source Sans 3"/>
               </a:rPr>
-              <a:t>Custos fixos</a:t>
+              <a:t>Margem de contribuição</a:t>
             </a:r>
           </a:p>
         </p:txBody>
@@ -6751,8 +6751,8 @@
         </p:nvSpPr>
         <p:spPr>
           <a:xfrm>
-            <a:off x="6867525" y="6109246"/>
-            <a:ext cx="3245941" cy="19050"/>
+            <a:off x="8441829" y="6109246"/>
+            <a:ext cx="3036689" cy="19050"/>
           </a:xfrm>
           <a:prstGeom prst="rect">
             <a:avLst/>
@@ -6778,8 +6778,8 @@
         </p:nvSpPr>
         <p:spPr>
           <a:xfrm>
-            <a:off x="6649611" y="5520982"/>
-            <a:ext cx="3216206" cy="381000"/>
+            <a:off x="8244840" y="5520982"/>
+            <a:ext cx="2986028" cy="381000"/>
           </a:xfrm>
           <a:prstGeom prst="rect">
             <a:avLst/>
@@ -6805,7 +6805,7 @@
                 <a:cs typeface="Source Sans 3"/>
                 <a:sym typeface="Source Sans 3"/>
               </a:rPr>
-              <a:t>43 mil</a:t>
+              <a:t>297 mil (32%)</a:t>
             </a:r>
           </a:p>
         </p:txBody>
@@ -6818,8 +6818,8 @@
         </p:nvSpPr>
         <p:spPr>
           <a:xfrm>
-            <a:off x="10113466" y="6109246"/>
-            <a:ext cx="3116461" cy="19050"/>
+            <a:off x="11478518" y="6109246"/>
+            <a:ext cx="2833092" cy="19050"/>
           </a:xfrm>
           <a:prstGeom prst="rect">
             <a:avLst/>
@@ -6845,8 +6845,8 @@
         </p:nvSpPr>
         <p:spPr>
           <a:xfrm>
-            <a:off x="9908500" y="5520982"/>
-            <a:ext cx="3073777" cy="381000"/>
+            <a:off x="11301889" y="5520982"/>
+            <a:ext cx="2762071" cy="381000"/>
           </a:xfrm>
           <a:prstGeom prst="rect">
             <a:avLst/>
@@ -6872,7 +6872,7 @@
                 <a:cs typeface="Source Sans 3"/>
                 <a:sym typeface="Source Sans 3"/>
               </a:rPr>
-              <a:t>154 mil</a:t>
+              <a:t>1,6 mi (33%)</a:t>
             </a:r>
           </a:p>
         </p:txBody>
@@ -6885,8 +6885,8 @@
         </p:nvSpPr>
         <p:spPr>
           <a:xfrm>
-            <a:off x="13229927" y="6109246"/>
-            <a:ext cx="3915073" cy="19050"/>
+            <a:off x="14311610" y="6109246"/>
+            <a:ext cx="2833390" cy="19050"/>
           </a:xfrm>
           <a:prstGeom prst="rect">
             <a:avLst/>
@@ -6912,8 +6912,8 @@
         </p:nvSpPr>
         <p:spPr>
           <a:xfrm>
-            <a:off x="12945100" y="5520982"/>
-            <a:ext cx="3952250" cy="381000"/>
+            <a:off x="14134951" y="5520982"/>
+            <a:ext cx="2762399" cy="381000"/>
           </a:xfrm>
           <a:prstGeom prst="rect">
             <a:avLst/>
@@ -6939,7 +6939,7 @@
                 <a:cs typeface="Source Sans 3"/>
                 <a:sym typeface="Source Sans 3"/>
               </a:rPr>
-              <a:t>405 mil</a:t>
+              <a:t>4,8 mi (33%)</a:t>
             </a:r>
           </a:p>
         </p:txBody>
@@ -6953,7 +6953,7 @@
         <p:spPr>
           <a:xfrm>
             <a:off x="1143000" y="6852196"/>
-            <a:ext cx="5724525" cy="19050"/>
+            <a:ext cx="7298829" cy="19050"/>
           </a:xfrm>
           <a:prstGeom prst="rect">
             <a:avLst/>
@@ -6980,7 +6980,7 @@
         <p:spPr>
           <a:xfrm>
             <a:off x="1390650" y="6263932"/>
-            <a:ext cx="780187" cy="381000"/>
+            <a:ext cx="7674382" cy="381000"/>
           </a:xfrm>
           <a:prstGeom prst="rect">
             <a:avLst/>
@@ -6997,7 +6997,7 @@
               </a:lnSpc>
             </a:pPr>
             <a:r>
-              <a:rPr b="1" sz="2100" kern="100">
+              <a:rPr b="0" sz="2100" kern="100">
                 <a:solidFill>
                   <a:srgbClr val="0F2B2A"/>
                 </a:solidFill>
@@ -7006,7 +7006,7 @@
                 <a:cs typeface="Source Sans 3"/>
                 <a:sym typeface="Source Sans 3"/>
               </a:rPr>
-              <a:t>EBIT</a:t>
+              <a:t>Custos fixos</a:t>
             </a:r>
           </a:p>
         </p:txBody>
@@ -7019,8 +7019,8 @@
         </p:nvSpPr>
         <p:spPr>
           <a:xfrm>
-            <a:off x="6867525" y="6852196"/>
-            <a:ext cx="3245941" cy="19050"/>
+            <a:off x="8441829" y="6852196"/>
+            <a:ext cx="3036689" cy="19050"/>
           </a:xfrm>
           <a:prstGeom prst="rect">
             <a:avLst/>
@@ -7046,8 +7046,8 @@
         </p:nvSpPr>
         <p:spPr>
           <a:xfrm>
-            <a:off x="6649611" y="6263932"/>
-            <a:ext cx="3216206" cy="381000"/>
+            <a:off x="8244840" y="6263932"/>
+            <a:ext cx="2986028" cy="381000"/>
           </a:xfrm>
           <a:prstGeom prst="rect">
             <a:avLst/>
@@ -7066,14 +7066,14 @@
             <a:r>
               <a:rPr b="0" sz="2100" kern="100">
                 <a:solidFill>
-                  <a:srgbClr val="B42318"/>
+                  <a:srgbClr val="0F2B2A"/>
                 </a:solidFill>
                 <a:latin typeface="Source Sans 3"/>
                 <a:ea typeface="Source Sans 3"/>
                 <a:cs typeface="Source Sans 3"/>
                 <a:sym typeface="Source Sans 3"/>
               </a:rPr>
-              <a:t>−28 mil</a:t>
+              <a:t>660 mil</a:t>
             </a:r>
           </a:p>
         </p:txBody>
@@ -7086,8 +7086,8 @@
         </p:nvSpPr>
         <p:spPr>
           <a:xfrm>
-            <a:off x="10113466" y="6852196"/>
-            <a:ext cx="3116461" cy="19050"/>
+            <a:off x="11478518" y="6852196"/>
+            <a:ext cx="2833092" cy="19050"/>
           </a:xfrm>
           <a:prstGeom prst="rect">
             <a:avLst/>
@@ -7113,8 +7113,8 @@
         </p:nvSpPr>
         <p:spPr>
           <a:xfrm>
-            <a:off x="9908500" y="6263932"/>
-            <a:ext cx="3073777" cy="381000"/>
+            <a:off x="11301889" y="6263932"/>
+            <a:ext cx="2762071" cy="381000"/>
           </a:xfrm>
           <a:prstGeom prst="rect">
             <a:avLst/>
@@ -7133,14 +7133,14 @@
             <a:r>
               <a:rPr b="0" sz="2100" kern="100">
                 <a:solidFill>
-                  <a:srgbClr val="B42318"/>
+                  <a:srgbClr val="0F2B2A"/>
                 </a:solidFill>
                 <a:latin typeface="Source Sans 3"/>
                 <a:ea typeface="Source Sans 3"/>
                 <a:cs typeface="Source Sans 3"/>
                 <a:sym typeface="Source Sans 3"/>
               </a:rPr>
-              <a:t>−74 mil</a:t>
+              <a:t>1,4 mi</a:t>
             </a:r>
           </a:p>
         </p:txBody>
@@ -7153,8 +7153,8 @@
         </p:nvSpPr>
         <p:spPr>
           <a:xfrm>
-            <a:off x="13229927" y="6852196"/>
-            <a:ext cx="3915073" cy="19050"/>
+            <a:off x="14311610" y="6852196"/>
+            <a:ext cx="2833390" cy="19050"/>
           </a:xfrm>
           <a:prstGeom prst="rect">
             <a:avLst/>
@@ -7180,8 +7180,8 @@
         </p:nvSpPr>
         <p:spPr>
           <a:xfrm>
-            <a:off x="12945100" y="6263932"/>
-            <a:ext cx="3952250" cy="381000"/>
+            <a:off x="14134951" y="6263932"/>
+            <a:ext cx="2762399" cy="381000"/>
           </a:xfrm>
           <a:prstGeom prst="rect">
             <a:avLst/>
@@ -7198,16 +7198,16 @@
               </a:lnSpc>
             </a:pPr>
             <a:r>
-              <a:rPr b="1" sz="2100" kern="100">
-                <a:solidFill>
-                  <a:srgbClr val="1D7A4B"/>
+              <a:rPr b="0" sz="2100" kern="100">
+                <a:solidFill>
+                  <a:srgbClr val="0F2B2A"/>
                 </a:solidFill>
                 <a:latin typeface="Source Sans 3"/>
                 <a:ea typeface="Source Sans 3"/>
                 <a:cs typeface="Source Sans 3"/>
                 <a:sym typeface="Source Sans 3"/>
               </a:rPr>
-              <a:t>+31 mil</a:t>
+              <a:t>2,5 mi</a:t>
             </a:r>
           </a:p>
         </p:txBody>
@@ -7221,7 +7221,7 @@
         <p:spPr>
           <a:xfrm>
             <a:off x="1143000" y="7595146"/>
-            <a:ext cx="5724525" cy="19050"/>
+            <a:ext cx="7298829" cy="19050"/>
           </a:xfrm>
           <a:prstGeom prst="rect">
             <a:avLst/>
@@ -7248,7 +7248,7 @@
         <p:spPr>
           <a:xfrm>
             <a:off x="1390650" y="7006882"/>
-            <a:ext cx="5942648" cy="381000"/>
+            <a:ext cx="780187" cy="381000"/>
           </a:xfrm>
           <a:prstGeom prst="rect">
             <a:avLst/>
@@ -7265,7 +7265,7 @@
               </a:lnSpc>
             </a:pPr>
             <a:r>
-              <a:rPr b="0" sz="2100" kern="100">
+              <a:rPr b="1" sz="2100" kern="100">
                 <a:solidFill>
                   <a:srgbClr val="0F2B2A"/>
                 </a:solidFill>
@@ -7274,7 +7274,7 @@
                 <a:cs typeface="Source Sans 3"/>
                 <a:sym typeface="Source Sans 3"/>
               </a:rPr>
-              <a:t>Atendimentos/mês para EBIT = 0</a:t>
+              <a:t>EBIT</a:t>
             </a:r>
           </a:p>
         </p:txBody>
@@ -7287,8 +7287,8 @@
         </p:nvSpPr>
         <p:spPr>
           <a:xfrm>
-            <a:off x="6867525" y="7595146"/>
-            <a:ext cx="3245941" cy="19050"/>
+            <a:off x="8441829" y="7595146"/>
+            <a:ext cx="3036689" cy="19050"/>
           </a:xfrm>
           <a:prstGeom prst="rect">
             <a:avLst/>
@@ -7314,8 +7314,8 @@
         </p:nvSpPr>
         <p:spPr>
           <a:xfrm>
-            <a:off x="6649611" y="7006882"/>
-            <a:ext cx="3216206" cy="381000"/>
+            <a:off x="8244840" y="7006882"/>
+            <a:ext cx="2986028" cy="381000"/>
           </a:xfrm>
           <a:prstGeom prst="rect">
             <a:avLst/>
@@ -7334,14 +7334,14 @@
             <a:r>
               <a:rPr b="0" sz="2100" kern="100">
                 <a:solidFill>
-                  <a:srgbClr val="0F2B2A"/>
+                  <a:srgbClr val="B42318"/>
                 </a:solidFill>
                 <a:latin typeface="Source Sans 3"/>
                 <a:ea typeface="Source Sans 3"/>
                 <a:cs typeface="Source Sans 3"/>
                 <a:sym typeface="Source Sans 3"/>
               </a:rPr>
-              <a:t>~870</a:t>
+              <a:t>−369 mil</a:t>
             </a:r>
           </a:p>
         </p:txBody>
@@ -7354,8 +7354,8 @@
         </p:nvSpPr>
         <p:spPr>
           <a:xfrm>
-            <a:off x="10113466" y="7595146"/>
-            <a:ext cx="3116461" cy="19050"/>
+            <a:off x="11478518" y="7595146"/>
+            <a:ext cx="2833092" cy="19050"/>
           </a:xfrm>
           <a:prstGeom prst="rect">
             <a:avLst/>
@@ -7381,8 +7381,8 @@
         </p:nvSpPr>
         <p:spPr>
           <a:xfrm>
-            <a:off x="9908500" y="7006882"/>
-            <a:ext cx="3073777" cy="381000"/>
+            <a:off x="11301889" y="7006882"/>
+            <a:ext cx="2762071" cy="381000"/>
           </a:xfrm>
           <a:prstGeom prst="rect">
             <a:avLst/>
@@ -7399,16 +7399,16 @@
               </a:lnSpc>
             </a:pPr>
             <a:r>
-              <a:rPr b="0" sz="2100" kern="100">
-                <a:solidFill>
-                  <a:srgbClr val="0F2B2A"/>
+              <a:rPr b="1" sz="2100" kern="100">
+                <a:solidFill>
+                  <a:srgbClr val="1D7A4B"/>
                 </a:solidFill>
                 <a:latin typeface="Source Sans 3"/>
                 <a:ea typeface="Source Sans 3"/>
                 <a:cs typeface="Source Sans 3"/>
                 <a:sym typeface="Source Sans 3"/>
               </a:rPr>
-              <a:t>~3.100</a:t>
+              <a:t>+147 mil</a:t>
             </a:r>
           </a:p>
         </p:txBody>
@@ -7421,8 +7421,8 @@
         </p:nvSpPr>
         <p:spPr>
           <a:xfrm>
-            <a:off x="13229927" y="7595146"/>
-            <a:ext cx="3915073" cy="19050"/>
+            <a:off x="14311610" y="7595146"/>
+            <a:ext cx="2833390" cy="19050"/>
           </a:xfrm>
           <a:prstGeom prst="rect">
             <a:avLst/>
@@ -7448,8 +7448,8 @@
         </p:nvSpPr>
         <p:spPr>
           <a:xfrm>
-            <a:off x="12945100" y="7006882"/>
-            <a:ext cx="3952250" cy="381000"/>
+            <a:off x="14134951" y="7006882"/>
+            <a:ext cx="2762399" cy="381000"/>
           </a:xfrm>
           <a:prstGeom prst="rect">
             <a:avLst/>
@@ -7466,30 +7466,57 @@
               </a:lnSpc>
             </a:pPr>
             <a:r>
-              <a:rPr b="0" sz="2100" kern="100">
-                <a:solidFill>
-                  <a:srgbClr val="0F2B2A"/>
+              <a:rPr b="1" sz="2100" kern="100">
+                <a:solidFill>
+                  <a:srgbClr val="1D7A4B"/>
                 </a:solidFill>
                 <a:latin typeface="Source Sans 3"/>
                 <a:ea typeface="Source Sans 3"/>
                 <a:cs typeface="Source Sans 3"/>
                 <a:sym typeface="Source Sans 3"/>
               </a:rPr>
-              <a:t>~7.300</a:t>
-            </a:r>
-          </a:p>
-        </p:txBody>
-      </p:sp>
-      <p:sp>
-        <p:nvSpPr>
-          <p:cNvPr id="66" name="TextBox 65"/>
-          <p:cNvSpPr txBox="1"/>
-          <p:nvPr/>
-        </p:nvSpPr>
-        <p:spPr>
-          <a:xfrm>
-            <a:off x="1143000" y="9163425"/>
-            <a:ext cx="17792700" cy="285750"/>
+              <a:t>+2,2 mi</a:t>
+            </a:r>
+          </a:p>
+        </p:txBody>
+      </p:sp>
+      <p:sp>
+        <p:nvSpPr>
+          <p:cNvPr id="66" name="Rectangle 65"/>
+          <p:cNvSpPr/>
+          <p:nvPr/>
+        </p:nvSpPr>
+        <p:spPr>
+          <a:xfrm>
+            <a:off x="1143000" y="8338096"/>
+            <a:ext cx="7298829" cy="19050"/>
+          </a:xfrm>
+          <a:prstGeom prst="rect">
+            <a:avLst/>
+          </a:prstGeom>
+          <a:solidFill>
+            <a:srgbClr val="F4F8F7"/>
+          </a:solidFill>
+          <a:ln>
+            <a:noFill/>
+          </a:ln>
+        </p:spPr>
+        <p:txBody>
+          <a:bodyPr rtlCol="0" anchor="ctr"/>
+          <a:lstStyle/>
+          <a:p/>
+        </p:txBody>
+      </p:sp>
+      <p:sp>
+        <p:nvSpPr>
+          <p:cNvPr id="67" name="TextBox 66"/>
+          <p:cNvSpPr txBox="1"/>
+          <p:nvPr/>
+        </p:nvSpPr>
+        <p:spPr>
+          <a:xfrm>
+            <a:off x="1390650" y="7749832"/>
+            <a:ext cx="7674382" cy="381000"/>
           </a:xfrm>
           <a:prstGeom prst="rect">
             <a:avLst/>
@@ -7502,27 +7529,268 @@
           <a:p>
             <a:pPr algn="l">
               <a:lnSpc>
-                <a:spcPts val="2242"/>
-              </a:lnSpc>
-            </a:pPr>
-            <a:r>
-              <a:rPr b="0" sz="1575" kern="100">
-                <a:solidFill>
-                  <a:srgbClr val="4A6261"/>
+                <a:spcPts val="2990"/>
+              </a:lnSpc>
+            </a:pPr>
+            <a:r>
+              <a:rPr b="0" sz="2100" kern="100">
+                <a:solidFill>
+                  <a:srgbClr val="0F2B2A"/>
                 </a:solidFill>
                 <a:latin typeface="Source Sans 3"/>
                 <a:ea typeface="Source Sans 3"/>
                 <a:cs typeface="Source Sans 3"/>
                 <a:sym typeface="Source Sans 3"/>
               </a:rPr>
-              <a:t>Todas as premissas são editáveis em docs/zelo-ebit-preliminar.xlsx. Alavancas: preço do acompanhante, percentual retido pelo Zelo e Zelo Empresas.</a:t>
-            </a:r>
-          </a:p>
-        </p:txBody>
-      </p:sp>
-      <p:sp>
-        <p:nvSpPr>
-          <p:cNvPr id="67" name="TextBox 66"/>
+              <a:t>EBIT acumulado</a:t>
+            </a:r>
+          </a:p>
+        </p:txBody>
+      </p:sp>
+      <p:sp>
+        <p:nvSpPr>
+          <p:cNvPr id="68" name="Rectangle 67"/>
+          <p:cNvSpPr/>
+          <p:nvPr/>
+        </p:nvSpPr>
+        <p:spPr>
+          <a:xfrm>
+            <a:off x="8441829" y="8338096"/>
+            <a:ext cx="3036689" cy="19050"/>
+          </a:xfrm>
+          <a:prstGeom prst="rect">
+            <a:avLst/>
+          </a:prstGeom>
+          <a:solidFill>
+            <a:srgbClr val="F4F8F7"/>
+          </a:solidFill>
+          <a:ln>
+            <a:noFill/>
+          </a:ln>
+        </p:spPr>
+        <p:txBody>
+          <a:bodyPr rtlCol="0" anchor="ctr"/>
+          <a:lstStyle/>
+          <a:p/>
+        </p:txBody>
+      </p:sp>
+      <p:sp>
+        <p:nvSpPr>
+          <p:cNvPr id="69" name="TextBox 68"/>
+          <p:cNvSpPr txBox="1"/>
+          <p:nvPr/>
+        </p:nvSpPr>
+        <p:spPr>
+          <a:xfrm>
+            <a:off x="8244840" y="7749832"/>
+            <a:ext cx="2986028" cy="381000"/>
+          </a:xfrm>
+          <a:prstGeom prst="rect">
+            <a:avLst/>
+          </a:prstGeom>
+          <a:noFill/>
+        </p:spPr>
+        <p:txBody>
+          <a:bodyPr wrap="square" lIns="0" rIns="0" tIns="0" bIns="0" anchor="t"/>
+          <a:lstStyle/>
+          <a:p>
+            <a:pPr algn="r">
+              <a:lnSpc>
+                <a:spcPts val="2990"/>
+              </a:lnSpc>
+            </a:pPr>
+            <a:r>
+              <a:rPr b="0" sz="2100" kern="100">
+                <a:solidFill>
+                  <a:srgbClr val="B42318"/>
+                </a:solidFill>
+                <a:latin typeface="Source Sans 3"/>
+                <a:ea typeface="Source Sans 3"/>
+                <a:cs typeface="Source Sans 3"/>
+                <a:sym typeface="Source Sans 3"/>
+              </a:rPr>
+              <a:t>−369 mil</a:t>
+            </a:r>
+          </a:p>
+        </p:txBody>
+      </p:sp>
+      <p:sp>
+        <p:nvSpPr>
+          <p:cNvPr id="70" name="Rectangle 69"/>
+          <p:cNvSpPr/>
+          <p:nvPr/>
+        </p:nvSpPr>
+        <p:spPr>
+          <a:xfrm>
+            <a:off x="11478518" y="8338096"/>
+            <a:ext cx="2833092" cy="19050"/>
+          </a:xfrm>
+          <a:prstGeom prst="rect">
+            <a:avLst/>
+          </a:prstGeom>
+          <a:solidFill>
+            <a:srgbClr val="F4F8F7"/>
+          </a:solidFill>
+          <a:ln>
+            <a:noFill/>
+          </a:ln>
+        </p:spPr>
+        <p:txBody>
+          <a:bodyPr rtlCol="0" anchor="ctr"/>
+          <a:lstStyle/>
+          <a:p/>
+        </p:txBody>
+      </p:sp>
+      <p:sp>
+        <p:nvSpPr>
+          <p:cNvPr id="71" name="TextBox 70"/>
+          <p:cNvSpPr txBox="1"/>
+          <p:nvPr/>
+        </p:nvSpPr>
+        <p:spPr>
+          <a:xfrm>
+            <a:off x="11301889" y="7749832"/>
+            <a:ext cx="2762071" cy="381000"/>
+          </a:xfrm>
+          <a:prstGeom prst="rect">
+            <a:avLst/>
+          </a:prstGeom>
+          <a:noFill/>
+        </p:spPr>
+        <p:txBody>
+          <a:bodyPr wrap="square" lIns="0" rIns="0" tIns="0" bIns="0" anchor="t"/>
+          <a:lstStyle/>
+          <a:p>
+            <a:pPr algn="r">
+              <a:lnSpc>
+                <a:spcPts val="2990"/>
+              </a:lnSpc>
+            </a:pPr>
+            <a:r>
+              <a:rPr b="0" sz="2100" kern="100">
+                <a:solidFill>
+                  <a:srgbClr val="B42318"/>
+                </a:solidFill>
+                <a:latin typeface="Source Sans 3"/>
+                <a:ea typeface="Source Sans 3"/>
+                <a:cs typeface="Source Sans 3"/>
+                <a:sym typeface="Source Sans 3"/>
+              </a:rPr>
+              <a:t>−221 mil</a:t>
+            </a:r>
+          </a:p>
+        </p:txBody>
+      </p:sp>
+      <p:sp>
+        <p:nvSpPr>
+          <p:cNvPr id="72" name="Rectangle 71"/>
+          <p:cNvSpPr/>
+          <p:nvPr/>
+        </p:nvSpPr>
+        <p:spPr>
+          <a:xfrm>
+            <a:off x="14311610" y="8338096"/>
+            <a:ext cx="2833390" cy="19050"/>
+          </a:xfrm>
+          <a:prstGeom prst="rect">
+            <a:avLst/>
+          </a:prstGeom>
+          <a:solidFill>
+            <a:srgbClr val="F4F8F7"/>
+          </a:solidFill>
+          <a:ln>
+            <a:noFill/>
+          </a:ln>
+        </p:spPr>
+        <p:txBody>
+          <a:bodyPr rtlCol="0" anchor="ctr"/>
+          <a:lstStyle/>
+          <a:p/>
+        </p:txBody>
+      </p:sp>
+      <p:sp>
+        <p:nvSpPr>
+          <p:cNvPr id="73" name="TextBox 72"/>
+          <p:cNvSpPr txBox="1"/>
+          <p:nvPr/>
+        </p:nvSpPr>
+        <p:spPr>
+          <a:xfrm>
+            <a:off x="14134951" y="7749832"/>
+            <a:ext cx="2762399" cy="381000"/>
+          </a:xfrm>
+          <a:prstGeom prst="rect">
+            <a:avLst/>
+          </a:prstGeom>
+          <a:noFill/>
+        </p:spPr>
+        <p:txBody>
+          <a:bodyPr wrap="square" lIns="0" rIns="0" tIns="0" bIns="0" anchor="t"/>
+          <a:lstStyle/>
+          <a:p>
+            <a:pPr algn="r">
+              <a:lnSpc>
+                <a:spcPts val="2990"/>
+              </a:lnSpc>
+            </a:pPr>
+            <a:r>
+              <a:rPr b="1" sz="2100" kern="100">
+                <a:solidFill>
+                  <a:srgbClr val="1D7A4B"/>
+                </a:solidFill>
+                <a:latin typeface="Source Sans 3"/>
+                <a:ea typeface="Source Sans 3"/>
+                <a:cs typeface="Source Sans 3"/>
+                <a:sym typeface="Source Sans 3"/>
+              </a:rPr>
+              <a:t>+2,0 mi</a:t>
+            </a:r>
+          </a:p>
+        </p:txBody>
+      </p:sp>
+      <p:sp>
+        <p:nvSpPr>
+          <p:cNvPr id="74" name="TextBox 73"/>
+          <p:cNvSpPr txBox="1"/>
+          <p:nvPr/>
+        </p:nvSpPr>
+        <p:spPr>
+          <a:xfrm>
+            <a:off x="1143000" y="9163425"/>
+            <a:ext cx="17792700" cy="285750"/>
+          </a:xfrm>
+          <a:prstGeom prst="rect">
+            <a:avLst/>
+          </a:prstGeom>
+          <a:noFill/>
+        </p:spPr>
+        <p:txBody>
+          <a:bodyPr wrap="square" lIns="0" rIns="0" tIns="0" bIns="0" anchor="t"/>
+          <a:lstStyle/>
+          <a:p>
+            <a:pPr algn="l">
+              <a:lnSpc>
+                <a:spcPts val="2242"/>
+              </a:lnSpc>
+            </a:pPr>
+            <a:r>
+              <a:rPr b="0" sz="1575" kern="100">
+                <a:solidFill>
+                  <a:srgbClr val="4A6261"/>
+                </a:solidFill>
+                <a:latin typeface="Source Sans 3"/>
+                <a:ea typeface="Source Sans 3"/>
+                <a:cs typeface="Source Sans 3"/>
+                <a:sym typeface="Source Sans 3"/>
+              </a:rPr>
+              <a:t>Sem a mensalidade das empresas (R$ 5 por funcionário), o EBIT do ano 3 seria −257 mil. Premissas editáveis em docs/zelo-ebit-preliminar.xlsx.</a:t>
+            </a:r>
+          </a:p>
+        </p:txBody>
+      </p:sp>
+      <p:sp>
+        <p:nvSpPr>
+          <p:cNvPr id="75" name="TextBox 74"/>
           <p:cNvSpPr txBox="1"/>
           <p:nvPr/>
         </p:nvSpPr>
@@ -7562,7 +7830,7 @@
       </p:sp>
       <p:sp>
         <p:nvSpPr>
-          <p:cNvPr id="68" name="Rounded Rectangle 67"/>
+          <p:cNvPr id="76" name="Rounded Rectangle 75"/>
           <p:cNvSpPr/>
           <p:nvPr/>
         </p:nvSpPr>
@@ -7591,7 +7859,7 @@
       </p:sp>
       <p:pic>
         <p:nvPicPr>
-          <p:cNvPr id="69" name="Picture 68" descr="r1_3.png"/>
+          <p:cNvPr id="77" name="Picture 76" descr="r1_3.png"/>
           <p:cNvPicPr>
             <a:picLocks noChangeAspect="1"/>
           </p:cNvPicPr>
@@ -7615,7 +7883,7 @@
       </p:pic>
       <p:sp>
         <p:nvSpPr>
-          <p:cNvPr id="70" name="TextBox 69"/>
+          <p:cNvPr id="78" name="TextBox 77"/>
           <p:cNvSpPr txBox="1"/>
           <p:nvPr/>
         </p:nvSpPr>
@@ -14318,7 +14586,19 @@
                 <a:cs typeface="Lexend SemiBold"/>
                 <a:sym typeface="Lexend SemiBold"/>
               </a:rPr>
-              <a:t>RH paga</a:t>
+              <a:t>R$ 5 </a:t>
+            </a:r>
+            <a:r>
+              <a:rPr b="0" sz="1800" kern="100">
+                <a:solidFill>
+                  <a:srgbClr val="4A6261"/>
+                </a:solidFill>
+                <a:latin typeface="Lexend Medium"/>
+                <a:ea typeface="Lexend Medium"/>
+                <a:cs typeface="Lexend Medium"/>
+                <a:sym typeface="Lexend Medium"/>
+              </a:rPr>
+              <a:t>/funcionário</a:t>
             </a:r>
           </a:p>
         </p:txBody>
@@ -14358,7 +14638,7 @@
                 <a:cs typeface="Source Sans 3"/>
                 <a:sym typeface="Source Sans 3"/>
               </a:rPr>
-              <a:t>Benefício para quem cuida dos pais. Menos faltas no trabalho.</a:t>
+              <a:t>A empresa paga por todos; quem cuida dos pais usa sem taxa.</a:t>
             </a:r>
           </a:p>
         </p:txBody>

</xml_diff>